<commit_message>
Blorps: master catches up with its PDFs; no week-later tally
The 10 Oct fixes (fold line a third of the way in, "Keep going until
time's up.", one slip per person) were made to the PDFs only; they're
now in the .pptx, and both PDFs are re-exported from it. The answers
page drops its "Day 3 (a week)" column and "keep the slips for Day 3":
slips are for today, and the next session asks out loud.

Also removes slides/cognitive_load_good.pdf: nothing linked to it.

Co-Authored-By: Claude Opus 5.5 <noreply@anthropic.com>
</commit_message>
<xml_diff>
--- a/tools/printables/blorps-and-fizzwicks.pptx
+++ b/tools/printables/blorps-and-fizzwicks.pptx
@@ -3256,7 +3256,24 @@
                 </a:solidFill>
                 <a:latin typeface="Aptos"/>
               </a:rPr>
-              <a:t>You have 3 minutes. Read the list. Then read it again. Keep reading it until the time's up.</a:t>
+              <a:t>You have 3 minutes. Read the list. Then read it again.</a:t>
+            </a:r>
+            <a:br>
+              <a:rPr sz="1300" b="0" i="0" u="none">
+                <a:solidFill>
+                  <a:srgbClr val="333333"/>
+                </a:solidFill>
+                <a:latin typeface="Aptos"/>
+              </a:rPr>
+            </a:br>
+            <a:r>
+              <a:rPr sz="1300" b="0" i="0" u="none">
+                <a:solidFill>
+                  <a:srgbClr val="333333"/>
+                </a:solidFill>
+                <a:latin typeface="Aptos"/>
+              </a:rPr>
+              <a:t>Keep going until time's up.</a:t>
             </a:r>
           </a:p>
         </p:txBody>
@@ -4249,7 +4266,7 @@
                 </a:solidFill>
                 <a:latin typeface="Aptos"/>
               </a:rPr>
-              <a:t>You have 3 minutes. Read the list once. Then fold the right half back along the dotted line, so the meanings are hidden. Look at each word and say its meaning (out loud or in your head). Unfold and check. Fold again and repeat until the time's up.</a:t>
+              <a:t>You have 3 minutes. Read the list once. Then fold the right side across to the dotted line, so the meanings are hidden. Look at each word and say its meaning (out loud or in your head). Unfold and check. Fold again and repeat until time's up.</a:t>
             </a:r>
           </a:p>
         </p:txBody>
@@ -4263,7 +4280,7 @@
         <p:spPr>
           <a:xfrm>
             <a:off x="432000" y="2736000"/>
-            <a:ext cx="3168000" cy="792000"/>
+            <a:ext cx="2160000" cy="792000"/>
           </a:xfrm>
           <a:prstGeom prst="rect">
             <a:avLst/>
@@ -4297,7 +4314,7 @@
         </p:nvSpPr>
         <p:spPr>
           <a:xfrm>
-            <a:off x="3960000" y="2736000"/>
+            <a:off x="2880000" y="2736000"/>
             <a:ext cx="3240000" cy="792000"/>
           </a:xfrm>
           <a:prstGeom prst="rect">
@@ -4333,7 +4350,7 @@
         <p:spPr>
           <a:xfrm>
             <a:off x="432000" y="3528000"/>
-            <a:ext cx="3168000" cy="792000"/>
+            <a:ext cx="2160000" cy="792000"/>
           </a:xfrm>
           <a:prstGeom prst="rect">
             <a:avLst/>
@@ -4367,7 +4384,7 @@
         </p:nvSpPr>
         <p:spPr>
           <a:xfrm>
-            <a:off x="3960000" y="3528000"/>
+            <a:off x="2880000" y="3528000"/>
             <a:ext cx="3240000" cy="792000"/>
           </a:xfrm>
           <a:prstGeom prst="rect">
@@ -4438,7 +4455,7 @@
         <p:spPr>
           <a:xfrm>
             <a:off x="432000" y="4320000"/>
-            <a:ext cx="3168000" cy="792000"/>
+            <a:ext cx="2160000" cy="792000"/>
           </a:xfrm>
           <a:prstGeom prst="rect">
             <a:avLst/>
@@ -4472,7 +4489,7 @@
         </p:nvSpPr>
         <p:spPr>
           <a:xfrm>
-            <a:off x="3960000" y="4320000"/>
+            <a:off x="2880000" y="4320000"/>
             <a:ext cx="3240000" cy="792000"/>
           </a:xfrm>
           <a:prstGeom prst="rect">
@@ -4543,7 +4560,7 @@
         <p:spPr>
           <a:xfrm>
             <a:off x="432000" y="5112000"/>
-            <a:ext cx="3168000" cy="792000"/>
+            <a:ext cx="2160000" cy="792000"/>
           </a:xfrm>
           <a:prstGeom prst="rect">
             <a:avLst/>
@@ -4577,7 +4594,7 @@
         </p:nvSpPr>
         <p:spPr>
           <a:xfrm>
-            <a:off x="3960000" y="5112000"/>
+            <a:off x="2880000" y="5112000"/>
             <a:ext cx="3240000" cy="792000"/>
           </a:xfrm>
           <a:prstGeom prst="rect">
@@ -4648,7 +4665,7 @@
         <p:spPr>
           <a:xfrm>
             <a:off x="432000" y="5904000"/>
-            <a:ext cx="3168000" cy="792000"/>
+            <a:ext cx="2160000" cy="792000"/>
           </a:xfrm>
           <a:prstGeom prst="rect">
             <a:avLst/>
@@ -4682,7 +4699,7 @@
         </p:nvSpPr>
         <p:spPr>
           <a:xfrm>
-            <a:off x="3960000" y="5904000"/>
+            <a:off x="2880000" y="5904000"/>
             <a:ext cx="3240000" cy="792000"/>
           </a:xfrm>
           <a:prstGeom prst="rect">
@@ -4753,7 +4770,7 @@
         <p:spPr>
           <a:xfrm>
             <a:off x="432000" y="6696000"/>
-            <a:ext cx="3168000" cy="792000"/>
+            <a:ext cx="2160000" cy="792000"/>
           </a:xfrm>
           <a:prstGeom prst="rect">
             <a:avLst/>
@@ -4787,7 +4804,7 @@
         </p:nvSpPr>
         <p:spPr>
           <a:xfrm>
-            <a:off x="3960000" y="6696000"/>
+            <a:off x="2880000" y="6696000"/>
             <a:ext cx="3240000" cy="792000"/>
           </a:xfrm>
           <a:prstGeom prst="rect">
@@ -4858,7 +4875,7 @@
         <p:spPr>
           <a:xfrm>
             <a:off x="432000" y="7488000"/>
-            <a:ext cx="3168000" cy="792000"/>
+            <a:ext cx="2160000" cy="792000"/>
           </a:xfrm>
           <a:prstGeom prst="rect">
             <a:avLst/>
@@ -4892,7 +4909,7 @@
         </p:nvSpPr>
         <p:spPr>
           <a:xfrm>
-            <a:off x="3960000" y="7488000"/>
+            <a:off x="2880000" y="7488000"/>
             <a:ext cx="3240000" cy="792000"/>
           </a:xfrm>
           <a:prstGeom prst="rect">
@@ -4963,7 +4980,7 @@
         <p:spPr>
           <a:xfrm>
             <a:off x="432000" y="8280000"/>
-            <a:ext cx="3168000" cy="792000"/>
+            <a:ext cx="2160000" cy="792000"/>
           </a:xfrm>
           <a:prstGeom prst="rect">
             <a:avLst/>
@@ -4997,7 +5014,7 @@
         </p:nvSpPr>
         <p:spPr>
           <a:xfrm>
-            <a:off x="3960000" y="8280000"/>
+            <a:off x="2880000" y="8280000"/>
             <a:ext cx="3240000" cy="792000"/>
           </a:xfrm>
           <a:prstGeom prst="rect">
@@ -5067,7 +5084,7 @@
         </p:nvCxnSpPr>
         <p:spPr>
           <a:xfrm>
-            <a:off x="3780000" y="2448000"/>
+            <a:off x="2664000" y="2448000"/>
             <a:ext cx="0" cy="6768000"/>
           </a:xfrm>
           <a:prstGeom prst="line">
@@ -5103,7 +5120,7 @@
         </p:nvSpPr>
         <p:spPr>
           <a:xfrm>
-            <a:off x="3060000" y="2232000"/>
+            <a:off x="1944000" y="2232000"/>
             <a:ext cx="1440000" cy="216000"/>
           </a:xfrm>
           <a:prstGeom prst="rect">
@@ -5125,7 +5142,7 @@
                 </a:solidFill>
                 <a:latin typeface="Aptos"/>
               </a:rPr>
-              <a:t>fold here</a:t>
+              <a:t>Fold right side to here</a:t>
             </a:r>
           </a:p>
         </p:txBody>
@@ -5178,7 +5195,7 @@
                 </a:solidFill>
                 <a:latin typeface="Aptos"/>
               </a:rPr>
-              <a:t>Retest slips · two per page · print enough for today AND Day 3</a:t>
+              <a:t>Retest slips · two per page · print one slip per person</a:t>
             </a:r>
           </a:p>
         </p:txBody>
@@ -7157,7 +7174,7 @@
         <p:spPr>
           <a:xfrm>
             <a:off x="432000" y="4032000"/>
-            <a:ext cx="2232000" cy="576000"/>
+            <a:ext cx="3348000" cy="576000"/>
           </a:xfrm>
           <a:prstGeom prst="rect">
             <a:avLst/>
@@ -7210,8 +7227,8 @@
         </p:nvSpPr>
         <p:spPr>
           <a:xfrm>
-            <a:off x="2664000" y="4032000"/>
-            <a:ext cx="2232000" cy="576000"/>
+            <a:off x="3780000" y="4032000"/>
+            <a:ext cx="3348000" cy="576000"/>
           </a:xfrm>
           <a:prstGeom prst="rect">
             <a:avLst/>
@@ -7258,14 +7275,14 @@
       </p:sp>
       <p:sp>
         <p:nvSpPr>
-          <p:cNvPr id="16" name="Rectangle 15"/>
+          <p:cNvPr id="17" name="Rectangle 16"/>
           <p:cNvSpPr/>
           <p:nvPr/>
         </p:nvSpPr>
         <p:spPr>
           <a:xfrm>
-            <a:off x="4896000" y="4032000"/>
-            <a:ext cx="2232000" cy="576000"/>
+            <a:off x="432000" y="4608000"/>
+            <a:ext cx="3348000" cy="576000"/>
           </a:xfrm>
           <a:prstGeom prst="rect">
             <a:avLst/>
@@ -7305,21 +7322,21 @@
                 </a:solidFill>
                 <a:latin typeface="Aptos"/>
               </a:rPr>
-              <a:t>Day 3 (a week)</a:t>
-            </a:r>
-          </a:p>
-        </p:txBody>
-      </p:sp>
-      <p:sp>
-        <p:nvSpPr>
-          <p:cNvPr id="17" name="Rectangle 16"/>
+              <a:t>Group A: re-read</a:t>
+            </a:r>
+          </a:p>
+        </p:txBody>
+      </p:sp>
+      <p:sp>
+        <p:nvSpPr>
+          <p:cNvPr id="18" name="Rectangle 17"/>
           <p:cNvSpPr/>
           <p:nvPr/>
         </p:nvSpPr>
         <p:spPr>
           <a:xfrm>
-            <a:off x="432000" y="4608000"/>
-            <a:ext cx="2232000" cy="576000"/>
+            <a:off x="3780000" y="4608000"/>
+            <a:ext cx="3348000" cy="576000"/>
           </a:xfrm>
           <a:prstGeom prst="rect">
             <a:avLst/>
@@ -7353,27 +7370,27 @@
           <a:p>
             <a:pPr algn="ctr"/>
             <a:r>
-              <a:rPr sz="1200" b="1" i="0" u="none">
+              <a:rPr sz="1200" b="0" i="0" u="none">
                 <a:solidFill>
                   <a:srgbClr val="333333"/>
                 </a:solidFill>
                 <a:latin typeface="Aptos"/>
               </a:rPr>
-              <a:t>Group A: re-read</a:t>
-            </a:r>
-          </a:p>
-        </p:txBody>
-      </p:sp>
-      <p:sp>
-        <p:nvSpPr>
-          <p:cNvPr id="18" name="Rectangle 17"/>
+              <a:t/>
+            </a:r>
+          </a:p>
+        </p:txBody>
+      </p:sp>
+      <p:sp>
+        <p:nvSpPr>
+          <p:cNvPr id="20" name="Rectangle 19"/>
           <p:cNvSpPr/>
           <p:nvPr/>
         </p:nvSpPr>
         <p:spPr>
           <a:xfrm>
-            <a:off x="2664000" y="4608000"/>
-            <a:ext cx="2232000" cy="576000"/>
+            <a:off x="432000" y="5184000"/>
+            <a:ext cx="3348000" cy="576000"/>
           </a:xfrm>
           <a:prstGeom prst="rect">
             <a:avLst/>
@@ -7407,27 +7424,27 @@
           <a:p>
             <a:pPr algn="ctr"/>
             <a:r>
-              <a:rPr sz="1200" b="0" i="0" u="none">
+              <a:rPr sz="1200" b="1" i="0" u="none">
                 <a:solidFill>
                   <a:srgbClr val="333333"/>
                 </a:solidFill>
                 <a:latin typeface="Aptos"/>
               </a:rPr>
-              <a:t/>
-            </a:r>
-          </a:p>
-        </p:txBody>
-      </p:sp>
-      <p:sp>
-        <p:nvSpPr>
-          <p:cNvPr id="19" name="Rectangle 18"/>
+              <a:t>Group B: self-test</a:t>
+            </a:r>
+          </a:p>
+        </p:txBody>
+      </p:sp>
+      <p:sp>
+        <p:nvSpPr>
+          <p:cNvPr id="21" name="Rectangle 20"/>
           <p:cNvSpPr/>
           <p:nvPr/>
         </p:nvSpPr>
         <p:spPr>
           <a:xfrm>
-            <a:off x="4896000" y="4608000"/>
-            <a:ext cx="2232000" cy="576000"/>
+            <a:off x="3780000" y="5184000"/>
+            <a:ext cx="3348000" cy="576000"/>
           </a:xfrm>
           <a:prstGeom prst="rect">
             <a:avLst/>
@@ -7474,168 +7491,6 @@
       </p:sp>
       <p:sp>
         <p:nvSpPr>
-          <p:cNvPr id="20" name="Rectangle 19"/>
-          <p:cNvSpPr/>
-          <p:nvPr/>
-        </p:nvSpPr>
-        <p:spPr>
-          <a:xfrm>
-            <a:off x="432000" y="5184000"/>
-            <a:ext cx="2232000" cy="576000"/>
-          </a:xfrm>
-          <a:prstGeom prst="rect">
-            <a:avLst/>
-          </a:prstGeom>
-          <a:noFill/>
-          <a:ln w="9525">
-            <a:solidFill>
-              <a:srgbClr val="999999"/>
-            </a:solidFill>
-            <a:prstDash val="dash"/>
-          </a:ln>
-          <a:effectLst/>
-        </p:spPr>
-        <p:style>
-          <a:lnRef idx="1">
-            <a:schemeClr val="accent1"/>
-          </a:lnRef>
-          <a:fillRef idx="3">
-            <a:schemeClr val="accent1"/>
-          </a:fillRef>
-          <a:effectRef idx="2">
-            <a:schemeClr val="accent1"/>
-          </a:effectRef>
-          <a:fontRef idx="minor">
-            <a:schemeClr val="lt1"/>
-          </a:fontRef>
-        </p:style>
-        <p:txBody>
-          <a:bodyPr rtlCol="0" anchor="ctr" wrap="square" lIns="72000" rIns="72000" tIns="72000" bIns="72000"/>
-          <a:lstStyle/>
-          <a:p>
-            <a:pPr algn="ctr"/>
-            <a:r>
-              <a:rPr sz="1200" b="1" i="0" u="none">
-                <a:solidFill>
-                  <a:srgbClr val="333333"/>
-                </a:solidFill>
-                <a:latin typeface="Aptos"/>
-              </a:rPr>
-              <a:t>Group B: self-test</a:t>
-            </a:r>
-          </a:p>
-        </p:txBody>
-      </p:sp>
-      <p:sp>
-        <p:nvSpPr>
-          <p:cNvPr id="21" name="Rectangle 20"/>
-          <p:cNvSpPr/>
-          <p:nvPr/>
-        </p:nvSpPr>
-        <p:spPr>
-          <a:xfrm>
-            <a:off x="2664000" y="5184000"/>
-            <a:ext cx="2232000" cy="576000"/>
-          </a:xfrm>
-          <a:prstGeom prst="rect">
-            <a:avLst/>
-          </a:prstGeom>
-          <a:noFill/>
-          <a:ln w="9525">
-            <a:solidFill>
-              <a:srgbClr val="999999"/>
-            </a:solidFill>
-            <a:prstDash val="dash"/>
-          </a:ln>
-          <a:effectLst/>
-        </p:spPr>
-        <p:style>
-          <a:lnRef idx="1">
-            <a:schemeClr val="accent1"/>
-          </a:lnRef>
-          <a:fillRef idx="3">
-            <a:schemeClr val="accent1"/>
-          </a:fillRef>
-          <a:effectRef idx="2">
-            <a:schemeClr val="accent1"/>
-          </a:effectRef>
-          <a:fontRef idx="minor">
-            <a:schemeClr val="lt1"/>
-          </a:fontRef>
-        </p:style>
-        <p:txBody>
-          <a:bodyPr rtlCol="0" anchor="ctr" wrap="square" lIns="72000" rIns="72000" tIns="72000" bIns="72000"/>
-          <a:lstStyle/>
-          <a:p>
-            <a:pPr algn="ctr"/>
-            <a:r>
-              <a:rPr sz="1200" b="0" i="0" u="none">
-                <a:solidFill>
-                  <a:srgbClr val="333333"/>
-                </a:solidFill>
-                <a:latin typeface="Aptos"/>
-              </a:rPr>
-              <a:t/>
-            </a:r>
-          </a:p>
-        </p:txBody>
-      </p:sp>
-      <p:sp>
-        <p:nvSpPr>
-          <p:cNvPr id="22" name="Rectangle 21"/>
-          <p:cNvSpPr/>
-          <p:nvPr/>
-        </p:nvSpPr>
-        <p:spPr>
-          <a:xfrm>
-            <a:off x="4896000" y="5184000"/>
-            <a:ext cx="2232000" cy="576000"/>
-          </a:xfrm>
-          <a:prstGeom prst="rect">
-            <a:avLst/>
-          </a:prstGeom>
-          <a:noFill/>
-          <a:ln w="9525">
-            <a:solidFill>
-              <a:srgbClr val="999999"/>
-            </a:solidFill>
-            <a:prstDash val="dash"/>
-          </a:ln>
-          <a:effectLst/>
-        </p:spPr>
-        <p:style>
-          <a:lnRef idx="1">
-            <a:schemeClr val="accent1"/>
-          </a:lnRef>
-          <a:fillRef idx="3">
-            <a:schemeClr val="accent1"/>
-          </a:fillRef>
-          <a:effectRef idx="2">
-            <a:schemeClr val="accent1"/>
-          </a:effectRef>
-          <a:fontRef idx="minor">
-            <a:schemeClr val="lt1"/>
-          </a:fontRef>
-        </p:style>
-        <p:txBody>
-          <a:bodyPr rtlCol="0" anchor="ctr" wrap="square" lIns="72000" rIns="72000" tIns="72000" bIns="72000"/>
-          <a:lstStyle/>
-          <a:p>
-            <a:pPr algn="ctr"/>
-            <a:r>
-              <a:rPr sz="1200" b="0" i="0" u="none">
-                <a:solidFill>
-                  <a:srgbClr val="333333"/>
-                </a:solidFill>
-                <a:latin typeface="Aptos"/>
-              </a:rPr>
-              <a:t/>
-            </a:r>
-          </a:p>
-        </p:txBody>
-      </p:sp>
-      <p:sp>
-        <p:nvSpPr>
           <p:cNvPr id="23" name="TextBox 22"/>
           <p:cNvSpPr txBox="1"/>
           <p:nvPr/>
@@ -7688,7 +7543,7 @@
                 </a:solidFill>
                 <a:latin typeface="Aptos"/>
               </a:rPr>
-              <a:t>Keep the slips (names on) for Day 3.</a:t>
+              <a:t>Slips are for today only. Next session (or the last block of a one-day), ask “who remembers what a blorp is?” out loud: no slips.</a:t>
             </a:r>
           </a:p>
         </p:txBody>

</xml_diff>